<commit_message>
VA-Track: Workbooks + Web-Inhalte nach VRNU-Praktiker-Feedback
- Content: VA00/M06/M13 (Produktnamen im Overview aktualisiert)
- Workbook-PDFs neu (Handlungsempfehlung-Renderer 'Wenn/Dann', Haus-Steckbrief, Produktnamen, Sachkorrekturen)
- Decks VA00/M17 (BankingManager)

Co-Authored-By: Claude Opus 4.8 <noreply@anthropic.com>
</commit_message>
<xml_diff>
--- a/protected-downloads/praesentation/VA00.pptx
+++ b/protected-downloads/praesentation/VA00.pptx
@@ -797,7 +797,7 @@
           <a:lstStyle/>
           <a:p>
             <a:r>
-              <a:t>Zuordnungslogik: agree = Kernsystem für Kundendaten, VR-NetWorld = Kunde bedient selbst. Bankgeheimnis/DSGVO als Grundregel ab Tag 1 verankern.</a:t>
+              <a:t>Zuordnungslogik: agree = Kernsystem für Kundendaten, BankingManager = Kunde bedient selbst. Bankgeheimnis/DSGVO als Grundregel ab Tag 1 verankern.</a:t>
             </a:r>
           </a:p>
         </p:txBody>
@@ -942,7 +942,7 @@
           </a:p>
           <a:p>
             <a:r>
-              <a:t>Kernpunkte: Votum = immer Marktfolge; agree = Kernsystem für Kundendaten; VR-NetWorld = Kundenportal, kein Innendienst-Zugang.</a:t>
+              <a:t>Kernpunkte: Votum = immer Marktfolge; agree = Kernsystem für Kundendaten; BankingManager = Kundenportal, kein Innendienst-Zugang.</a:t>
             </a:r>
           </a:p>
           <a:p>
@@ -5602,7 +5602,7 @@
                 </a:solidFill>
                 <a:latin typeface="Arial"/>
               </a:rPr>
-              <a:t>▸  M365 für Office/Kommunikation; VR-NetWorld ist das Kundenportal – kein Innendienst-Zugang.</a:t>
+              <a:t>▸  M365 für Office/Kommunikation; BankingManager ist das Kundenportal – kein Innendienst-Zugang.</a:t>
             </a:r>
           </a:p>
           <a:p>
@@ -8131,7 +8131,7 @@
                 </a:solidFill>
                 <a:latin typeface="Arial"/>
               </a:rPr>
-              <a:t>▸  Typische Innendienst-Aufgaben dem zuständigen System (agree, DMS, Microsoft 365, VR-NetWorld) und der richtigen Stelle zuordnen</a:t>
+              <a:t>▸  Typische Innendienst-Aufgaben dem zuständigen System (agree, DMS, Microsoft 365, BankingManager) und der richtigen Stelle zuordnen</a:t>
             </a:r>
           </a:p>
           <a:p>

</xml_diff>

<commit_message>
VA00-Deck + M17-Workbook: BankingManager als Banking-Software (nicht Portal)
Co-Authored-By: Claude Opus 4.8 <noreply@anthropic.com>
</commit_message>
<xml_diff>
--- a/protected-downloads/praesentation/VA00.pptx
+++ b/protected-downloads/praesentation/VA00.pptx
@@ -942,7 +942,7 @@
           </a:p>
           <a:p>
             <a:r>
-              <a:t>Kernpunkte: Votum = immer Marktfolge; agree = Kernsystem für Kundendaten; BankingManager = Kundenportal, kein Innendienst-Zugang.</a:t>
+              <a:t>Kernpunkte: Votum = immer Marktfolge; agree = Kernsystem für Kundendaten; BankingManager = Banking-Software (Kunde bedient selbst), kein Innendienst-Zugang.</a:t>
             </a:r>
           </a:p>
           <a:p>
@@ -5602,7 +5602,7 @@
                 </a:solidFill>
                 <a:latin typeface="Arial"/>
               </a:rPr>
-              <a:t>▸  M365 für Office/Kommunikation; BankingManager ist das Kundenportal – kein Innendienst-Zugang.</a:t>
+              <a:t>▸  M365 für Office/Kommunikation; BankingManager ist die Banking-Software, die der Firmenkunde selbst bedient – kein Innendienst-Zugang.</a:t>
             </a:r>
           </a:p>
           <a:p>

</xml_diff>